<commit_message>
Bớt chữ trên slide Chương 3, 4 và 5
Tiếp đợt bớt chữ, vẫn theo quy ước Chương 1 đã đặt: thân thẻ rút từ câu văn
28–41 chữ xuống cụm 8–14 chữ, đoạn văn bị rút đưa vào ghi chú giảng bài dưới
mục "NÓI ĐỦ Ý (phần đã rút khỏi slide)".

                trước      sau
  Chương 3      97,0  →   80,1 chữ/slide
  Chương 4      98,9  →   82,5
  Chương 5      91,8  →   78,9

Cả năm chương bài giảng nay nằm trong khoảng 76–83 chữ mỗi slide, thay vì
95–105 như trước.

91 thân thẻ đổi chữ, 20 khối NÓI ĐỦ Ý thêm vào ghi chú.

Không đụng tới slide hoạt động nhóm và slide bài tập — những slide ấy giao
nhiệm vụ cho sinh viên nên phải viết đủ, rút gọn là mất thông tin. Cũng
không đụng năm slide đã thay bằng hình, vì chữ trên đó bị add_images.py xoá
lúc dựng.

Đã chạy lại xuat_slide.py, 131 ảnh trong ứng dụng khớp bộ slide mới. Nâng
PHIEN_BAN lên comdraft-v20. Bộ kiểm tra 24/24.

Còn lại: ba bài thực hành (bai-2 vẫn 111 chữ/slide, dày nhất), và bộ slide
tiếng Anh.
</commit_message>
<xml_diff>
--- a/slides/03-tinh-huong-dac-thu.pptx
+++ b/slides/03-tinh-huong-dac-thu.pptx
@@ -720,6 +720,37 @@
               <a:t>• Mẹo thực dụng: nói chậm, rõ, và XÁC NHẬN LẠI BẰNG VĂN BẢN sau cuộc họp đa quốc gia.</a:t>
             </a:r>
           </a:p>
+          <a:p/>
+          <a:p>
+            <a:r>
+              <a:t>NÓI ĐỦ Ý (phần đã rút khỏi slide)</a:t>
+            </a:r>
+          </a:p>
+          <a:p>
+            <a:r>
+              <a:t>• Tìm hiểu trước mỗi cuộc gặp quan trọng, đừng đợi đến lúc ngồi vào bàn.</a:t>
+            </a:r>
+          </a:p>
+          <a:p>
+            <a:r>
+              <a:t>• Quan sát rồi ứng xử tương thích — bắt chước là cách học nhanh nhất.</a:t>
+            </a:r>
+          </a:p>
+          <a:p>
+            <a:r>
+              <a:t>• Hỏi lịch sự thay vì phán xét.</a:t>
+            </a:r>
+          </a:p>
+          <a:p>
+            <a:r>
+              <a:t>• Khác ngôn ngữ: nói chậm, rõ, tránh thành ngữ; tóm tắt thỏa thuận qua email sau họp.</a:t>
+            </a:r>
+          </a:p>
+          <a:p>
+            <a:r>
+              <a:t>• Thiện chí học hỏi luôn được ghi nhận ở mọi nền văn hóa.</a:t>
+            </a:r>
+          </a:p>
         </p:txBody>
       </p:sp>
       <p:sp>
@@ -1270,6 +1301,27 @@
               <a:t>• Khủng hoảng: phản hồi NHANH, nhận trách nhiệm đúng phần của mình.</a:t>
             </a:r>
           </a:p>
+          <a:p/>
+          <a:p>
+            <a:r>
+              <a:t>NÓI ĐỦ Ý (phần đã rút khỏi slide)</a:t>
+            </a:r>
+          </a:p>
+          <a:p>
+            <a:r>
+              <a:t>• Đối tác: quan hệ lâu dài quan trọng hơn lợi thế ngắn hạn — đây là nền cho Chương 4.</a:t>
+            </a:r>
+          </a:p>
+          <a:p>
+            <a:r>
+              <a:t>• Cơ quan nhà nước: hồ sơ, văn bản phải chuẩn thể thức (Chương 5); tác phong nghiêm túc, đúng hẹn; tuyệt đối không “đi tắt” trái quy định.</a:t>
+            </a:r>
+          </a:p>
+          <a:p>
+            <a:r>
+              <a:t>• Truyền thông: thông tin nhất quán, trung thực; khủng hoảng thì nhận trách nhiệm đúng phần của mình, không né tránh.</a:t>
+            </a:r>
+          </a:p>
         </p:txBody>
       </p:sp>
       <p:sp>
@@ -1607,6 +1659,27 @@
               <a:t>• Có ý kiến khác: chọn lúc riêng tư, dựa trên DỮ LIỆU và LỢI ÍCH CHUNG, và tôn trọng quyết định cuối.</a:t>
             </a:r>
           </a:p>
+          <a:p/>
+          <a:p>
+            <a:r>
+              <a:t>NÓI ĐỦ Ý (phần đã rút khỏi slide)</a:t>
+            </a:r>
+          </a:p>
+          <a:p>
+            <a:r>
+              <a:t>• Nhận nhiệm vụ: hỏi lại cho rõ YÊU CẦU, THỜI HẠN, NGUỒN LỰC — ba thứ này thiếu một là làm sai.</a:t>
+            </a:r>
+          </a:p>
+          <a:p>
+            <a:r>
+              <a:t>• Báo cáo: kết quả trước, diễn giải sau. Tin xấu báo SỚM và kèm phương án, đừng che giấu.</a:t>
+            </a:r>
+          </a:p>
+          <a:p>
+            <a:r>
+              <a:t>• Ý kiến khác: chọn lúc riêng tư; nói trên cơ sở dữ liệu và lợi ích chung; nói xong thì tôn trọng quyết định cuối cùng.</a:t>
+            </a:r>
+          </a:p>
         </p:txBody>
       </p:sp>
       <p:sp>
@@ -1713,6 +1786,32 @@
               <a:t>• Với đồng nghiệp: tranh luận về công việc, không công kích cá nhân; tránh bè phái.</a:t>
             </a:r>
           </a:p>
+          <a:p/>
+          <a:p>
+            <a:r>
+              <a:t>NÓI ĐỦ Ý (phần đã rút khỏi slide)</a:t>
+            </a:r>
+          </a:p>
+          <a:p>
+            <a:r>
+              <a:t>• Giao việc kèm NIỀM TIN và NGUỒN LỰC; kiểm tra tiến độ đúng mức, đừng quản lý vụn vặt.</a:t>
+            </a:r>
+          </a:p>
+          <a:p>
+            <a:r>
+              <a:t>• Khen thì công khai, kịp thời, cụ thể. Phê bình thì riêng tư, kèm hướng khắc phục.</a:t>
+            </a:r>
+          </a:p>
+          <a:p>
+            <a:r>
+              <a:t>• Đồng nghiệp: tránh bè phái, tránh tán chuyện sau lưng.</a:t>
+            </a:r>
+          </a:p>
+          <a:p>
+            <a:r>
+              <a:t>• Họp: có chương trình gửi trước, phát biểu ngắn gọn, kết thúc phải có biên bản và người chịu trách nhiệm từng việc.</a:t>
+            </a:r>
+          </a:p>
         </p:txBody>
       </p:sp>
       <p:sp>
@@ -1819,6 +1918,27 @@
               <a:t>CHUYỂN Ý: "Vậy khi khách nổi giận thì làm sao?"''</a:t>
             </a:r>
           </a:p>
+          <a:p/>
+          <a:p>
+            <a:r>
+              <a:t>NÓI ĐỦ Ý (phần đã rút khỏi slide)</a:t>
+            </a:r>
+          </a:p>
+          <a:p>
+            <a:r>
+              <a:t>• Mỗi điểm tiếp xúc — chào đón, tư vấn, giao hàng, hậu mãi — đều xây hoặc phá niềm tin.</a:t>
+            </a:r>
+          </a:p>
+          <a:p>
+            <a:r>
+              <a:t>• Nguyên tắc vàng: chào niềm nở, gọi TÊN khách khi có thể; nói sự thật về sản phẩm; giữ lời hứa về thời hạn.</a:t>
+            </a:r>
+          </a:p>
+          <a:p>
+            <a:r>
+              <a:t>• Tối kỵ: hứa quá khả năng; đổ lỗi cho đồng nghiệp hoặc cho quy trình; bỏ mặc khách sau khi bán xong.</a:t>
+            </a:r>
+          </a:p>
         </p:txBody>
       </p:sp>
       <p:sp>
@@ -2137,6 +2257,32 @@
           <a:p>
             <a:r>
               <a:t>• Chủ đề nên và không nên nói — nhấn: tránh chính trị, tôn giáo, thu nhập, đời tư.</a:t>
+            </a:r>
+          </a:p>
+          <a:p/>
+          <a:p>
+            <a:r>
+              <a:t>NÓI ĐỦ Ý (phần đã rút khỏi slide)</a:t>
+            </a:r>
+          </a:p>
+          <a:p>
+            <a:r>
+              <a:t>• Trước tiệc: trang phục theo tính chất tiệc; vị trí ngồi thể hiện thứ bậc nên phải chờ chủ tiệc xếp chỗ.</a:t>
+            </a:r>
+          </a:p>
+          <a:p>
+            <a:r>
+              <a:t>• Trong bữa: không nói khi đang nhai, không gõ đũa, không xoay đĩa thức ăn về phía mình liên tục.</a:t>
+            </a:r>
+          </a:p>
+          <a:p>
+            <a:r>
+              <a:t>• Chúc rượu: chúc ngắn gọn, đúng đối tượng; tôn trọng người không dùng rượu bia.</a:t>
+            </a:r>
+          </a:p>
+          <a:p>
+            <a:r>
+              <a:t>• Chuyện trò: công việc chỉ bàn khi chủ tiệc gợi mở.</a:t>
             </a:r>
           </a:p>
         </p:txBody>
@@ -3215,7 +3361,7 @@
                 <a:ea typeface="Calibri" pitchFamily="34" charset="-122"/>
                 <a:cs typeface="Calibri" pitchFamily="34" charset="-120"/>
               </a:rPr>
-              <a:t>Bình đẳng, giữ chữ tín, minh bạch thông tin; quan hệ lâu dài quan trọng hơn lợi thế ngắn hạn — nền tảng cho đàm phán ở Chương 4.</a:t>
+              <a:t>Giữ chữ tín, minh bạch; quan hệ lâu dài hơn lợi thế ngắn hạn</a:t>
             </a:r>
             <a:endParaRPr lang="en-US" sz="1500" dirty="0"/>
           </a:p>
@@ -3302,7 +3448,7 @@
                 <a:ea typeface="Calibri" pitchFamily="34" charset="-122"/>
                 <a:cs typeface="Calibri" pitchFamily="34" charset="-120"/>
               </a:rPr>
-              <a:t>Đúng thủ tục, đúng thẩm quyền, hồ sơ – văn bản chuẩn thể thức (Chương 5); tác phong nghiêm túc, đúng hẹn; tuyệt đối không “đi tắt” trái quy định.</a:t>
+              <a:t>Đúng thủ tục, đúng thẩm quyền, văn bản chuẩn thể thức</a:t>
             </a:r>
             <a:endParaRPr lang="en-US" sz="1500" dirty="0"/>
           </a:p>
@@ -3389,7 +3535,7 @@
                 <a:ea typeface="Calibri" pitchFamily="34" charset="-122"/>
                 <a:cs typeface="Calibri" pitchFamily="34" charset="-120"/>
               </a:rPr>
-              <a:t>Chỉ người được ủy quyền phát ngôn; thông tin nhất quán, trung thực; khi có khủng hoảng: phản hồi nhanh, nhận trách nhiệm đúng phần của mình, không né tránh.</a:t>
+              <a:t>Chỉ người được ủy quyền phát ngôn; khủng hoảng thì phản hồi nhanh</a:t>
             </a:r>
             <a:endParaRPr lang="en-US" sz="1500" dirty="0"/>
           </a:p>
@@ -4072,7 +4218,7 @@
                 <a:ea typeface="Calibri" pitchFamily="34" charset="-122"/>
                 <a:cs typeface="Calibri" pitchFamily="34" charset="-120"/>
               </a:rPr>
-              <a:t>Xác nhận tham dự đúng hạn; đến đúng giờ; trang phục theo tính chất tiệc; chờ chủ tiệc mời và xếp chỗ — vị trí ngồi thể hiện thứ bậc.</a:t>
+              <a:t>Xác nhận đúng hạn • đúng giờ • chờ chủ tiệc xếp chỗ</a:t>
             </a:r>
             <a:endParaRPr lang="en-US" sz="1500" dirty="0"/>
           </a:p>
@@ -4159,7 +4305,7 @@
                 <a:ea typeface="Calibri" pitchFamily="34" charset="-122"/>
                 <a:cs typeface="Calibri" pitchFamily="34" charset="-120"/>
               </a:rPr>
-              <a:t>Chủ tiệc bắt đầu trước; dùng dụng cụ từ ngoài vào trong; không nói khi đang nhai, không gõ đũa, không xoay đĩa thức ăn về phía mình liên tục.</a:t>
+              <a:t>Chủ tiệc bắt đầu trước; dụng cụ dùng từ ngoài vào trong</a:t>
             </a:r>
             <a:endParaRPr lang="en-US" sz="1500" dirty="0"/>
           </a:p>
@@ -4246,7 +4392,7 @@
                 <a:ea typeface="Calibri" pitchFamily="34" charset="-122"/>
                 <a:cs typeface="Calibri" pitchFamily="34" charset="-120"/>
               </a:rPr>
-              <a:t>Người vị thế thấp nâng ly thấp hơn khi cụng; chúc ngắn gọn, đúng đối tượng; tôn trọng người không dùng rượu bia — không ép.</a:t>
+              <a:t>Vị thế thấp nâng ly thấp hơn; không ép người không uống</a:t>
             </a:r>
             <a:endParaRPr lang="en-US" sz="1500" dirty="0"/>
           </a:p>
@@ -4333,7 +4479,7 @@
                 <a:ea typeface="Calibri" pitchFamily="34" charset="-122"/>
                 <a:cs typeface="Calibri" pitchFamily="34" charset="-120"/>
               </a:rPr>
-              <a:t>Chủ đề nhẹ nhàng: ẩm thực, thể thao, du lịch, quê quán; tránh chính trị, tôn giáo, thu nhập, đời tư; công việc chỉ bàn khi chủ tiệc gợi mở.</a:t>
+              <a:t>Nên: ẩm thực, thể thao, du lịch • Tránh: chính trị, tôn giáo, thu nhập</a:t>
             </a:r>
             <a:endParaRPr lang="en-US" sz="1500" dirty="0"/>
           </a:p>
@@ -5058,7 +5204,7 @@
                 <a:ea typeface="Calibri" pitchFamily="34" charset="-122"/>
                 <a:cs typeface="Calibri" pitchFamily="34" charset="-120"/>
               </a:rPr>
-              <a:t>văn hóa giao tiếp, nghi thức chào hỏi, kiêng kỵ của đối tác trước mỗi cuộc gặp quan trọng.</a:t>
+              <a:t>nghi thức chào hỏi và điều kiêng kỵ của đối tác</a:t>
             </a:r>
             <a:endParaRPr lang="en-US" sz="1400" dirty="0"/>
           </a:p>
@@ -5174,7 +5320,7 @@
                 <a:ea typeface="Calibri" pitchFamily="34" charset="-122"/>
                 <a:cs typeface="Calibri" pitchFamily="34" charset="-120"/>
               </a:rPr>
-              <a:t>để ý cách đối tác chào, trao danh thiếp, giữ khoảng cách… và ứng xử tương thích.</a:t>
+              <a:t>cách họ chào, trao danh thiếp, giữ khoảng cách</a:t>
             </a:r>
             <a:endParaRPr lang="en-US" sz="1400" dirty="0"/>
           </a:p>
@@ -5290,7 +5436,7 @@
                 <a:ea typeface="Calibri" pitchFamily="34" charset="-122"/>
                 <a:cs typeface="Calibri" pitchFamily="34" charset="-120"/>
               </a:rPr>
-              <a:t>một hành vi “kỳ lạ” có thể hoàn toàn bình thường trong văn hóa của họ — hỏi lịch sự thay vì phán xét.</a:t>
+              <a:t>hành vi “kỳ lạ” có thể rất bình thường với họ</a:t>
             </a:r>
             <a:endParaRPr lang="en-US" sz="1400" dirty="0"/>
           </a:p>
@@ -5406,7 +5552,7 @@
                 <a:ea typeface="Calibri" pitchFamily="34" charset="-122"/>
                 <a:cs typeface="Calibri" pitchFamily="34" charset="-120"/>
               </a:rPr>
-              <a:t>khi khác ngôn ngữ: tránh tiếng lóng, thành ngữ; tóm tắt thỏa thuận qua email sau cuộc họp.</a:t>
+              <a:t>tránh tiếng lóng; tóm tắt thỏa thuận qua email</a:t>
             </a:r>
             <a:endParaRPr lang="en-US" sz="1400" dirty="0"/>
           </a:p>
@@ -5522,7 +5668,7 @@
                 <a:ea typeface="Calibri" pitchFamily="34" charset="-122"/>
                 <a:cs typeface="Calibri" pitchFamily="34" charset="-120"/>
               </a:rPr>
-              <a:t>sẵn sàng xin lỗi khi lỡ phạm điều kiêng kỵ; thiện chí học hỏi luôn được ghi nhận ở mọi nền văn hóa.</a:t>
+              <a:t>xin lỗi khi lỡ phạm điều kiêng kỵ</a:t>
             </a:r>
             <a:endParaRPr lang="en-US" sz="1400" dirty="0"/>
           </a:p>
@@ -10253,7 +10399,7 @@
                 <a:ea typeface="Calibri" pitchFamily="34" charset="-122"/>
                 <a:cs typeface="Calibri" pitchFamily="34" charset="-120"/>
               </a:rPr>
-              <a:t>Lắng nghe – ghi chú – hỏi lại cho rõ yêu cầu, thời hạn, nguồn lực; xác nhận lại bằng tin nhắn/email để hai bên cùng hiểu một cách.</a:t>
+              <a:t>Nghe – ghi – hỏi lại cho rõ; xác nhận lại bằng email</a:t>
             </a:r>
             <a:endParaRPr lang="en-US" sz="1500" dirty="0"/>
           </a:p>
@@ -10340,7 +10486,7 @@
                 <a:ea typeface="Calibri" pitchFamily="34" charset="-122"/>
                 <a:cs typeface="Calibri" pitchFamily="34" charset="-120"/>
               </a:rPr>
-              <a:t>Chủ động, đúng hạn, kết quả trước – diễn giải sau; báo tin xấu sớm kèm phương án xử lý, không che giấu.</a:t>
+              <a:t>Kết quả trước, diễn giải sau; tin xấu báo sớm kèm phương án</a:t>
             </a:r>
             <a:endParaRPr lang="en-US" sz="1500" dirty="0"/>
           </a:p>
@@ -10427,7 +10573,7 @@
                 <a:ea typeface="Calibri" pitchFamily="34" charset="-122"/>
                 <a:cs typeface="Calibri" pitchFamily="34" charset="-120"/>
               </a:rPr>
-              <a:t>Chọn đúng lúc, đúng chỗ (thường là riêng tư); trình bày trên cơ sở dữ liệu và lợi ích chung; tôn trọng quyết định cuối cùng.</a:t>
+              <a:t>Đúng lúc, đúng chỗ, dựa trên dữ liệu; tôn trọng quyết định cuối</a:t>
             </a:r>
             <a:endParaRPr lang="en-US" sz="1500" dirty="0"/>
           </a:p>
@@ -10789,7 +10935,7 @@
                 <a:ea typeface="Calibri" pitchFamily="34" charset="-122"/>
                 <a:cs typeface="Calibri" pitchFamily="34" charset="-120"/>
               </a:rPr>
-              <a:t>Rõ mục tiêu – thời hạn – tiêu chuẩn; giao việc kèm niềm tin và nguồn lực; kiểm tra tiến độ đúng mức, không quản lý vụn vặt.</a:t>
+              <a:t>Rõ mục tiêu – thời hạn – tiêu chuẩn; giao kèm nguồn lực</a:t>
             </a:r>
             <a:endParaRPr lang="en-US" sz="1500" dirty="0"/>
           </a:p>
@@ -10876,7 +11022,7 @@
                 <a:ea typeface="Calibri" pitchFamily="34" charset="-122"/>
                 <a:cs typeface="Calibri" pitchFamily="34" charset="-120"/>
               </a:rPr>
-              <a:t>Khen công khai, kịp thời, cụ thể; phê bình riêng tư, nhắm vào hành vi chứ không nhắm vào con người, kèm hướng khắc phục.</a:t>
+              <a:t>Khen công khai • phê bình riêng tư, nhắm hành vi không nhắm người</a:t>
             </a:r>
             <a:endParaRPr lang="en-US" sz="1500" dirty="0"/>
           </a:p>
@@ -10963,7 +11109,7 @@
                 <a:ea typeface="Calibri" pitchFamily="34" charset="-122"/>
                 <a:cs typeface="Calibri" pitchFamily="34" charset="-120"/>
               </a:rPr>
-              <a:t>Tôn trọng, hợp tác, chia sẻ thông tin; tranh luận về công việc chứ không công kích cá nhân; tránh bè phái, tán chuyện sau lưng.</a:t>
+              <a:t>Tranh luận công việc, không công kích cá nhân; tránh bè phái</a:t>
             </a:r>
             <a:endParaRPr lang="en-US" sz="1500" dirty="0"/>
           </a:p>
@@ -11050,7 +11196,7 @@
                 <a:ea typeface="Calibri" pitchFamily="34" charset="-122"/>
                 <a:cs typeface="Calibri" pitchFamily="34" charset="-120"/>
               </a:rPr>
-              <a:t>Có chương trình gửi trước; đến đúng giờ; phát biểu ngắn gọn vào trọng tâm; có kết luận, biên bản và người chịu trách nhiệm từng việc.</a:t>
+              <a:t>Chương trình gửi trước • kết luận rõ • ai làm việc gì</a:t>
             </a:r>
             <a:endParaRPr lang="en-US" sz="1500" dirty="0"/>
           </a:p>
@@ -11733,7 +11879,7 @@
                 <a:ea typeface="Calibri" pitchFamily="34" charset="-122"/>
                 <a:cs typeface="Calibri" pitchFamily="34" charset="-120"/>
               </a:rPr>
-              <a:t>Khách hàng nuôi sống doanh nghiệp; mỗi điểm tiếp xúc (chào đón, tư vấn, giao hàng, hậu mãi) đều là khoảnh khắc xây hoặc phá niềm tin.</a:t>
+              <a:t>Mỗi điểm tiếp xúc là một khoảnh khắc xây hoặc phá niềm tin</a:t>
             </a:r>
             <a:endParaRPr lang="en-US" sz="1500" dirty="0"/>
           </a:p>
@@ -11820,7 +11966,7 @@
                 <a:ea typeface="Calibri" pitchFamily="34" charset="-122"/>
                 <a:cs typeface="Calibri" pitchFamily="34" charset="-120"/>
               </a:rPr>
-              <a:t>Chào đón niềm nở – gọi tên khách khi có thể; lắng nghe nhu cầu trước khi giới thiệu; nói sự thật về sản phẩm; giữ lời hứa về thời hạn.</a:t>
+              <a:t>Nghe nhu cầu trước khi giới thiệu • nói thật • giữ lời hứa</a:t>
             </a:r>
             <a:endParaRPr lang="en-US" sz="1500" dirty="0"/>
           </a:p>
@@ -11907,7 +12053,7 @@
                 <a:ea typeface="Calibri" pitchFamily="34" charset="-122"/>
                 <a:cs typeface="Calibri" pitchFamily="34" charset="-120"/>
               </a:rPr>
-              <a:t>Tranh cãi thắng – thua với khách; hứa quá khả năng; đổ lỗi cho đồng nghiệp, cho quy trình; bỏ mặc khách sau khi bán xong.</a:t>
+              <a:t>Cãi thắng thua • hứa quá khả năng • bỏ mặc sau khi bán</a:t>
             </a:r>
             <a:endParaRPr lang="en-US" sz="1500" dirty="0"/>
           </a:p>

</xml_diff>